<commit_message>
Part 1 + team: add portrait-photo team page as comparison (10 pages)
Co-Authored-By: Claude Opus 5.5 <noreply@anthropic.com>
Claude-Session: https://claude.ai/code/session_01NTagjVHGZdXLvG9VCNzDRT
</commit_message>
<xml_diff>
--- a/slides/Vitonaut_BP_part1_team.pptx
+++ b/slides/Vitonaut_BP_part1_team.pptx
@@ -17,6 +17,7 @@
     <p:sldId id="290" r:id="rId90"/>
     <p:sldId id="263" r:id="rId11"/>
     <p:sldId id="268" r:id="rId16"/>
+    <p:sldId id="291" r:id="rId91"/>
   </p:sldIdLst>
   <p:sldSz cx="12192000" cy="6858000"/>
   <p:notesSz cx="6858000" cy="9144000"/>
@@ -2847,7 +2848,7 @@
                 <a:ea typeface="微软雅黑"/>
                 <a:cs typeface="微软雅黑"/>
               </a:rPr>
-              <a:t>09 / 09</a:t>
+              <a:t>09 / 10</a:t>
             </a:r>
             <a:endParaRPr sz="1050">
               <a:solidFill>
@@ -3672,7 +3673,7 @@
                 <a:ea typeface="微软雅黑"/>
                 <a:cs typeface="微软雅黑"/>
               </a:rPr>
-              <a:t>05 / 09</a:t>
+              <a:t>05 / 10</a:t>
             </a:r>
             <a:endParaRPr sz="1050">
               <a:solidFill>
@@ -4629,7 +4630,7 @@
                 <a:ea typeface="微软雅黑"/>
                 <a:cs typeface="微软雅黑"/>
               </a:rPr>
-              <a:t>02 / 09</a:t>
+              <a:t>02 / 10</a:t>
             </a:r>
             <a:endParaRPr sz="1050">
               <a:solidFill>
@@ -5635,7 +5636,7 @@
                 <a:ea typeface="微软雅黑"/>
                 <a:cs typeface="微软雅黑"/>
               </a:rPr>
-              <a:t>07 / 09</a:t>
+              <a:t>07 / 10</a:t>
             </a:r>
             <a:endParaRPr sz="1050">
               <a:solidFill>
@@ -5651,6 +5652,1556 @@
       <p:sp>
         <p:nvSpPr>
           <p:cNvPr id="915" name="品牌页脚"/>
+          <p:cNvSpPr txBox="1"/>
+          <p:nvPr/>
+        </p:nvSpPr>
+        <p:spPr>
+          <a:xfrm>
+            <a:off x="530352" y="6382512"/>
+            <a:ext cx="7315200" cy="164592"/>
+          </a:xfrm>
+          <a:prstGeom prst="rect">
+            <a:avLst/>
+          </a:prstGeom>
+          <a:noFill/>
+        </p:spPr>
+        <p:txBody>
+          <a:bodyPr wrap="square" lIns="0" tIns="0" rIns="0" bIns="0" anchor="t">
+            <a:noAutofit/>
+          </a:bodyPr>
+          <a:lstStyle/>
+          <a:p>
+            <a:pPr algn="l">
+              <a:lnSpc>
+                <a:spcPct val="110000"/>
+              </a:lnSpc>
+              <a:buNone/>
+            </a:pPr>
+            <a:r>
+              <a:rPr lang="zh-CN" altLang="en-US" sz="1050">
+                <a:solidFill>
+                  <a:srgbClr val="808080"/>
+                </a:solidFill>
+                <a:latin typeface="微软雅黑"/>
+                <a:ea typeface="微软雅黑"/>
+                <a:cs typeface="微软雅黑"/>
+              </a:rPr>
+              <a:t>Vitonaut 维探 · AIVC 虚拟类器官 · 融资商业计划书</a:t>
+            </a:r>
+          </a:p>
+        </p:txBody>
+      </p:sp>
+    </p:spTree>
+  </p:cSld>
+  <p:clrMapOvr>
+    <a:masterClrMapping/>
+  </p:clrMapOvr>
+</p:sld>
+</file>
+
+<file path=ppt/slides/slide21.xml><?xml version="1.0" encoding="utf-8"?>
+<p:sld xmlns:a="http://schemas.openxmlformats.org/drawingml/2006/main" xmlns:r="http://schemas.openxmlformats.org/officeDocument/2006/relationships" xmlns:p="http://schemas.openxmlformats.org/presentationml/2006/main">
+  <p:cSld>
+    <p:spTree>
+      <p:nvGrpSpPr>
+        <p:cNvPr id="1" name=""/>
+        <p:cNvGrpSpPr/>
+        <p:nvPr/>
+      </p:nvGrpSpPr>
+      <p:grpSpPr/>
+      <p:sp>
+        <p:nvSpPr>
+          <p:cNvPr id="90" name="矩形 63"/>
+          <p:cNvSpPr>
+            <a:spLocks noGrp="1"/>
+          </p:cNvSpPr>
+          <p:nvPr/>
+        </p:nvSpPr>
+        <p:spPr>
+          <a:xfrm>
+            <a:off x="0" y="0"/>
+            <a:ext cx="12192000" cy="6858000"/>
+          </a:xfrm>
+          <a:prstGeom prst="rect">
+            <a:avLst/>
+          </a:prstGeom>
+          <a:solidFill>
+            <a:srgbClr val="FFFFFF"/>
+          </a:solidFill>
+        </p:spPr>
+        <p:txBody>
+          <a:bodyPr/>
+          <a:lstStyle/>
+          <a:p/>
+        </p:txBody>
+      </p:sp>
+      <p:sp>
+        <p:nvSpPr>
+          <p:cNvPr id="91" name="文本框 64"/>
+          <p:cNvSpPr>
+            <a:spLocks noGrp="1"/>
+          </p:cNvSpPr>
+          <p:nvPr/>
+        </p:nvSpPr>
+        <p:spPr>
+          <a:xfrm>
+            <a:off x="533400" y="419100"/>
+            <a:ext cx="11125200" cy="381000"/>
+          </a:xfrm>
+          <a:prstGeom prst="rect">
+            <a:avLst/>
+          </a:prstGeom>
+        </p:spPr>
+        <p:txBody>
+          <a:bodyPr wrap="none" lIns="0" tIns="0" rIns="0" bIns="0"/>
+          <a:lstStyle/>
+          <a:p>
+            <a:pPr>
+              <a:lnSpc>
+                <a:spcPct val="100000"/>
+              </a:lnSpc>
+              <a:buNone/>
+            </a:pPr>
+            <a:r>
+              <a:rPr sz="2475" b="1">
+                <a:solidFill>
+                  <a:srgbClr val="061F32"/>
+                </a:solidFill>
+                <a:latin typeface="微软雅黑"/>
+                <a:ea typeface="微软雅黑"/>
+                <a:cs typeface="微软雅黑"/>
+              </a:rPr>
+              <a:t>团队：科学 × 数据 × 模型 × 运营，核心能力</a:t>
+            </a:r>
+            <a:r>
+              <a:rPr lang="zh-CN" altLang="en-US" sz="2475" b="1">
+                <a:solidFill>
+                  <a:srgbClr val="061F32"/>
+                </a:solidFill>
+                <a:latin typeface="微软雅黑"/>
+                <a:ea typeface="微软雅黑"/>
+                <a:cs typeface="微软雅黑"/>
+              </a:rPr>
+              <a:t>实现</a:t>
+            </a:r>
+            <a:r>
+              <a:rPr sz="2475" b="1">
+                <a:solidFill>
+                  <a:srgbClr val="061F32"/>
+                </a:solidFill>
+                <a:latin typeface="微软雅黑"/>
+                <a:ea typeface="微软雅黑"/>
+                <a:cs typeface="微软雅黑"/>
+              </a:rPr>
+              <a:t>自持</a:t>
+            </a:r>
+            <a:r>
+              <a:rPr lang="zh-CN" altLang="en-US" sz="2475" b="1">
+                <a:solidFill>
+                  <a:srgbClr val="061F32"/>
+                </a:solidFill>
+                <a:latin typeface="微软雅黑"/>
+                <a:ea typeface="微软雅黑"/>
+                <a:cs typeface="微软雅黑"/>
+              </a:rPr>
+              <a:t>闭环</a:t>
+            </a:r>
+            <a:endParaRPr sz="2475" b="1">
+              <a:solidFill>
+                <a:srgbClr val="061F32"/>
+              </a:solidFill>
+              <a:latin typeface="微软雅黑"/>
+              <a:ea typeface="微软雅黑"/>
+              <a:cs typeface="微软雅黑"/>
+            </a:endParaRPr>
+          </a:p>
+        </p:txBody>
+      </p:sp>
+      <p:sp>
+        <p:nvSpPr>
+          <p:cNvPr id="92" name="矩形 65"/>
+          <p:cNvSpPr>
+            <a:spLocks noGrp="1"/>
+          </p:cNvSpPr>
+          <p:nvPr/>
+        </p:nvSpPr>
+        <p:spPr>
+          <a:xfrm>
+            <a:off x="533400" y="895350"/>
+            <a:ext cx="11125200" cy="9525"/>
+          </a:xfrm>
+          <a:prstGeom prst="rect">
+            <a:avLst/>
+          </a:prstGeom>
+          <a:solidFill>
+            <a:srgbClr val="061F32"/>
+          </a:solidFill>
+        </p:spPr>
+        <p:txBody>
+          <a:bodyPr/>
+          <a:lstStyle/>
+          <a:p/>
+        </p:txBody>
+      </p:sp>
+      <p:pic>
+        <p:nvPicPr>
+          <p:cNvPr id="301" name="照片 1"/>
+          <p:cNvPicPr>
+            <a:picLocks noChangeAspect="1"/>
+          </p:cNvPicPr>
+          <p:nvPr/>
+        </p:nvPicPr>
+        <p:blipFill>
+          <a:blip r:embed="rIdPh1"/>
+          <a:stretch>
+            <a:fillRect/>
+          </a:stretch>
+        </p:blipFill>
+        <p:spPr>
+          <a:xfrm>
+            <a:off x="1178433" y="1005840"/>
+            <a:ext cx="1280160" cy="1280160"/>
+          </a:xfrm>
+          <a:prstGeom prst="ellipse">
+            <a:avLst/>
+          </a:prstGeom>
+          <a:ln w="12700">
+            <a:solidFill>
+              <a:srgbClr val="99BDED"/>
+            </a:solidFill>
+          </a:ln>
+        </p:spPr>
+      </p:pic>
+      <p:sp>
+        <p:nvSpPr>
+          <p:cNvPr id="302" name="姓名 1"/>
+          <p:cNvSpPr txBox="1"/>
+          <p:nvPr/>
+        </p:nvSpPr>
+        <p:spPr>
+          <a:xfrm>
+            <a:off x="530352" y="2404872"/>
+            <a:ext cx="2576322" cy="329184"/>
+          </a:xfrm>
+          <a:prstGeom prst="rect">
+            <a:avLst/>
+          </a:prstGeom>
+          <a:noFill/>
+        </p:spPr>
+        <p:txBody>
+          <a:bodyPr wrap="square" lIns="0" tIns="0" rIns="0" bIns="0" anchor="ctr">
+            <a:noAutofit/>
+          </a:bodyPr>
+          <a:lstStyle/>
+          <a:p>
+            <a:pPr algn="ctr">
+              <a:lnSpc>
+                <a:spcPct val="112000"/>
+              </a:lnSpc>
+              <a:buNone/>
+            </a:pPr>
+            <a:r>
+              <a:rPr lang="zh-CN" altLang="en-US" sz="1600" b="1">
+                <a:solidFill>
+                  <a:srgbClr val="061F32"/>
+                </a:solidFill>
+                <a:latin typeface="微软雅黑"/>
+                <a:ea typeface="微软雅黑"/>
+                <a:cs typeface="微软雅黑"/>
+              </a:rPr>
+              <a:t>卓悦 博士</a:t>
+            </a:r>
+          </a:p>
+        </p:txBody>
+      </p:sp>
+      <p:sp>
+        <p:nvSpPr>
+          <p:cNvPr id="303" name="职位 1"/>
+          <p:cNvSpPr txBox="1"/>
+          <p:nvPr/>
+        </p:nvSpPr>
+        <p:spPr>
+          <a:xfrm>
+            <a:off x="530352" y="2724912"/>
+            <a:ext cx="2576322" cy="274320"/>
+          </a:xfrm>
+          <a:prstGeom prst="rect">
+            <a:avLst/>
+          </a:prstGeom>
+          <a:noFill/>
+        </p:spPr>
+        <p:txBody>
+          <a:bodyPr wrap="square" lIns="0" tIns="0" rIns="0" bIns="0" anchor="ctr">
+            <a:noAutofit/>
+          </a:bodyPr>
+          <a:lstStyle/>
+          <a:p>
+            <a:pPr algn="ctr">
+              <a:lnSpc>
+                <a:spcPct val="112000"/>
+              </a:lnSpc>
+              <a:buNone/>
+            </a:pPr>
+            <a:r>
+              <a:rPr lang="zh-CN" altLang="en-US" sz="1300" b="1">
+                <a:solidFill>
+                  <a:srgbClr val="08A6F6"/>
+                </a:solidFill>
+                <a:latin typeface="微软雅黑"/>
+                <a:ea typeface="微软雅黑"/>
+                <a:cs typeface="微软雅黑"/>
+              </a:rPr>
+              <a:t>CEO 首席执行官</a:t>
+            </a:r>
+          </a:p>
+        </p:txBody>
+      </p:sp>
+      <p:sp>
+        <p:nvSpPr>
+          <p:cNvPr id="304" name="亮点 1"/>
+          <p:cNvSpPr txBox="1"/>
+          <p:nvPr/>
+        </p:nvSpPr>
+        <p:spPr>
+          <a:xfrm>
+            <a:off x="530352" y="3017520"/>
+            <a:ext cx="2576322" cy="256032"/>
+          </a:xfrm>
+          <a:prstGeom prst="rect">
+            <a:avLst/>
+          </a:prstGeom>
+          <a:noFill/>
+        </p:spPr>
+        <p:txBody>
+          <a:bodyPr wrap="square" lIns="0" tIns="0" rIns="0" bIns="0" anchor="ctr">
+            <a:noAutofit/>
+          </a:bodyPr>
+          <a:lstStyle/>
+          <a:p>
+            <a:pPr algn="ctr">
+              <a:lnSpc>
+                <a:spcPct val="112000"/>
+              </a:lnSpc>
+              <a:buNone/>
+            </a:pPr>
+            <a:r>
+              <a:rPr lang="zh-CN" altLang="en-US" sz="1050">
+                <a:solidFill>
+                  <a:srgbClr val="44546A"/>
+                </a:solidFill>
+                <a:latin typeface="微软雅黑"/>
+                <a:ea typeface="微软雅黑"/>
+                <a:cs typeface="微软雅黑"/>
+              </a:rPr>
+              <a:t>湿实验 × 数据 × AI，全链路打通</a:t>
+            </a:r>
+          </a:p>
+        </p:txBody>
+      </p:sp>
+      <p:sp>
+        <p:nvSpPr>
+          <p:cNvPr id="305" name="经历 1"/>
+          <p:cNvSpPr txBox="1"/>
+          <p:nvPr/>
+        </p:nvSpPr>
+        <p:spPr>
+          <a:xfrm>
+            <a:off x="603504" y="3456432"/>
+            <a:ext cx="2484882" cy="2606040"/>
+          </a:xfrm>
+          <a:prstGeom prst="rect">
+            <a:avLst/>
+          </a:prstGeom>
+          <a:noFill/>
+        </p:spPr>
+        <p:txBody>
+          <a:bodyPr wrap="square" lIns="0" tIns="0" rIns="0" bIns="0" anchor="t">
+            <a:noAutofit/>
+          </a:bodyPr>
+          <a:lstStyle/>
+          <a:p>
+            <a:pPr algn="l" marL="190500" indent="-190500">
+              <a:lnSpc>
+                <a:spcPct val="110000"/>
+              </a:lnSpc>
+              <a:spcAft>
+                <a:spcPts val="450"/>
+              </a:spcAft>
+              <a:buClr>
+                <a:srgbClr val="08A6F6"/>
+              </a:buClr>
+              <a:buFont typeface="Arial"/>
+              <a:buChar char="•"/>
+            </a:pPr>
+            <a:r>
+              <a:rPr lang="zh-CN" altLang="en-US" sz="1150">
+                <a:solidFill>
+                  <a:srgbClr val="061F32"/>
+                </a:solidFill>
+                <a:latin typeface="微软雅黑"/>
+                <a:ea typeface="微软雅黑"/>
+                <a:cs typeface="微软雅黑"/>
+              </a:rPr>
+              <a:t>海德堡大学 / DKFZ 发育生物学博士</a:t>
+            </a:r>
+          </a:p>
+          <a:p>
+            <a:pPr algn="l" marL="190500" indent="-190500">
+              <a:lnSpc>
+                <a:spcPct val="110000"/>
+              </a:lnSpc>
+              <a:spcAft>
+                <a:spcPts val="450"/>
+              </a:spcAft>
+              <a:buClr>
+                <a:srgbClr val="08A6F6"/>
+              </a:buClr>
+              <a:buFont typeface="Arial"/>
+              <a:buChar char="•"/>
+            </a:pPr>
+            <a:r>
+              <a:rPr lang="zh-CN" altLang="en-US" sz="1150">
+                <a:solidFill>
+                  <a:srgbClr val="061F32"/>
+                </a:solidFill>
+                <a:latin typeface="微软雅黑"/>
+                <a:ea typeface="微软雅黑"/>
+                <a:cs typeface="微软雅黑"/>
+              </a:rPr>
+              <a:t>密歇根大学安娜堡分校学士</a:t>
+            </a:r>
+          </a:p>
+          <a:p>
+            <a:pPr algn="l" marL="190500" indent="-190500">
+              <a:lnSpc>
+                <a:spcPct val="110000"/>
+              </a:lnSpc>
+              <a:spcAft>
+                <a:spcPts val="450"/>
+              </a:spcAft>
+              <a:buClr>
+                <a:srgbClr val="08A6F6"/>
+              </a:buClr>
+              <a:buFont typeface="Arial"/>
+              <a:buChar char="•"/>
+            </a:pPr>
+            <a:r>
+              <a:rPr lang="zh-CN" altLang="en-US" sz="1150">
+                <a:solidFill>
+                  <a:srgbClr val="061F32"/>
+                </a:solidFill>
+                <a:latin typeface="微软雅黑"/>
+                <a:ea typeface="微软雅黑"/>
+                <a:cs typeface="微软雅黑"/>
+              </a:rPr>
+              <a:t>Verqura 实验室管理系统创始人</a:t>
+            </a:r>
+          </a:p>
+          <a:p>
+            <a:pPr algn="l" marL="190500" indent="-190500">
+              <a:lnSpc>
+                <a:spcPct val="110000"/>
+              </a:lnSpc>
+              <a:spcAft>
+                <a:spcPts val="450"/>
+              </a:spcAft>
+              <a:buClr>
+                <a:srgbClr val="08A6F6"/>
+              </a:buClr>
+              <a:buFont typeface="Arial"/>
+              <a:buChar char="•"/>
+            </a:pPr>
+            <a:r>
+              <a:rPr lang="zh-CN" altLang="en-US" sz="1150">
+                <a:solidFill>
+                  <a:srgbClr val="061F32"/>
+                </a:solidFill>
+                <a:latin typeface="微软雅黑"/>
+                <a:ea typeface="微软雅黑"/>
+                <a:cs typeface="微软雅黑"/>
+              </a:rPr>
+              <a:t>精通 iPSC 脑类器官构建、CRISPR 基因组编辑与标记</a:t>
+            </a:r>
+          </a:p>
+          <a:p>
+            <a:pPr algn="l" marL="190500" indent="-190500">
+              <a:lnSpc>
+                <a:spcPct val="110000"/>
+              </a:lnSpc>
+              <a:spcAft>
+                <a:spcPts val="450"/>
+              </a:spcAft>
+              <a:buClr>
+                <a:srgbClr val="08A6F6"/>
+              </a:buClr>
+              <a:buFont typeface="Arial"/>
+              <a:buChar char="•"/>
+            </a:pPr>
+            <a:r>
+              <a:rPr lang="zh-CN" altLang="en-US" sz="1150">
+                <a:solidFill>
+                  <a:srgbClr val="061F32"/>
+                </a:solidFill>
+                <a:latin typeface="微软雅黑"/>
+                <a:ea typeface="微软雅黑"/>
+                <a:cs typeface="微软雅黑"/>
+              </a:rPr>
+              <a:t>单细胞测序与 AI 图像分析（YOLO / Cellpose）</a:t>
+            </a:r>
+          </a:p>
+          <a:p>
+            <a:pPr algn="l" marL="190500" indent="-190500">
+              <a:lnSpc>
+                <a:spcPct val="110000"/>
+              </a:lnSpc>
+              <a:spcAft>
+                <a:spcPts val="450"/>
+              </a:spcAft>
+              <a:buClr>
+                <a:srgbClr val="08A6F6"/>
+              </a:buClr>
+              <a:buFont typeface="Arial"/>
+              <a:buChar char="•"/>
+            </a:pPr>
+            <a:r>
+              <a:rPr lang="zh-CN" altLang="en-US" sz="1150">
+                <a:solidFill>
+                  <a:srgbClr val="061F32"/>
+                </a:solidFill>
+                <a:latin typeface="微软雅黑"/>
+                <a:ea typeface="微软雅黑"/>
+                <a:cs typeface="微软雅黑"/>
+              </a:rPr>
+              <a:t>Cell Stem Cell 2025、npj Precision Oncology 2024 作者</a:t>
+            </a:r>
+          </a:p>
+        </p:txBody>
+      </p:sp>
+      <p:pic>
+        <p:nvPicPr>
+          <p:cNvPr id="306" name="照片 2"/>
+          <p:cNvPicPr>
+            <a:picLocks noChangeAspect="1"/>
+          </p:cNvPicPr>
+          <p:nvPr/>
+        </p:nvPicPr>
+        <p:blipFill>
+          <a:blip r:embed="rIdPh2"/>
+          <a:stretch>
+            <a:fillRect/>
+          </a:stretch>
+        </p:blipFill>
+        <p:spPr>
+          <a:xfrm>
+            <a:off x="4029075" y="1005840"/>
+            <a:ext cx="1280160" cy="1280160"/>
+          </a:xfrm>
+          <a:prstGeom prst="ellipse">
+            <a:avLst/>
+          </a:prstGeom>
+          <a:ln w="12700">
+            <a:solidFill>
+              <a:srgbClr val="99BDED"/>
+            </a:solidFill>
+          </a:ln>
+        </p:spPr>
+      </p:pic>
+      <p:sp>
+        <p:nvSpPr>
+          <p:cNvPr id="307" name="姓名 2"/>
+          <p:cNvSpPr txBox="1"/>
+          <p:nvPr/>
+        </p:nvSpPr>
+        <p:spPr>
+          <a:xfrm>
+            <a:off x="3380994" y="2404872"/>
+            <a:ext cx="2576322" cy="329184"/>
+          </a:xfrm>
+          <a:prstGeom prst="rect">
+            <a:avLst/>
+          </a:prstGeom>
+          <a:noFill/>
+        </p:spPr>
+        <p:txBody>
+          <a:bodyPr wrap="square" lIns="0" tIns="0" rIns="0" bIns="0" anchor="ctr">
+            <a:noAutofit/>
+          </a:bodyPr>
+          <a:lstStyle/>
+          <a:p>
+            <a:pPr algn="ctr">
+              <a:lnSpc>
+                <a:spcPct val="112000"/>
+              </a:lnSpc>
+              <a:buNone/>
+            </a:pPr>
+            <a:r>
+              <a:rPr lang="zh-CN" altLang="en-US" sz="1600" b="1">
+                <a:solidFill>
+                  <a:srgbClr val="061F32"/>
+                </a:solidFill>
+                <a:latin typeface="微软雅黑"/>
+                <a:ea typeface="微软雅黑"/>
+                <a:cs typeface="微软雅黑"/>
+              </a:rPr>
+              <a:t>田伟利 博士</a:t>
+            </a:r>
+          </a:p>
+        </p:txBody>
+      </p:sp>
+      <p:sp>
+        <p:nvSpPr>
+          <p:cNvPr id="308" name="职位 2"/>
+          <p:cNvSpPr txBox="1"/>
+          <p:nvPr/>
+        </p:nvSpPr>
+        <p:spPr>
+          <a:xfrm>
+            <a:off x="3380994" y="2724912"/>
+            <a:ext cx="2576322" cy="274320"/>
+          </a:xfrm>
+          <a:prstGeom prst="rect">
+            <a:avLst/>
+          </a:prstGeom>
+          <a:noFill/>
+        </p:spPr>
+        <p:txBody>
+          <a:bodyPr wrap="square" lIns="0" tIns="0" rIns="0" bIns="0" anchor="ctr">
+            <a:noAutofit/>
+          </a:bodyPr>
+          <a:lstStyle/>
+          <a:p>
+            <a:pPr algn="ctr">
+              <a:lnSpc>
+                <a:spcPct val="112000"/>
+              </a:lnSpc>
+              <a:buNone/>
+            </a:pPr>
+            <a:r>
+              <a:rPr lang="zh-CN" altLang="en-US" sz="1300" b="1">
+                <a:solidFill>
+                  <a:srgbClr val="08A6F6"/>
+                </a:solidFill>
+                <a:latin typeface="微软雅黑"/>
+                <a:ea typeface="微软雅黑"/>
+                <a:cs typeface="微软雅黑"/>
+              </a:rPr>
+              <a:t>CSO 首席科学官</a:t>
+            </a:r>
+          </a:p>
+        </p:txBody>
+      </p:sp>
+      <p:sp>
+        <p:nvSpPr>
+          <p:cNvPr id="309" name="亮点 2"/>
+          <p:cNvSpPr txBox="1"/>
+          <p:nvPr/>
+        </p:nvSpPr>
+        <p:spPr>
+          <a:xfrm>
+            <a:off x="3380994" y="3017520"/>
+            <a:ext cx="2576322" cy="256032"/>
+          </a:xfrm>
+          <a:prstGeom prst="rect">
+            <a:avLst/>
+          </a:prstGeom>
+          <a:noFill/>
+        </p:spPr>
+        <p:txBody>
+          <a:bodyPr wrap="square" lIns="0" tIns="0" rIns="0" bIns="0" anchor="ctr">
+            <a:noAutofit/>
+          </a:bodyPr>
+          <a:lstStyle/>
+          <a:p>
+            <a:pPr algn="ctr">
+              <a:lnSpc>
+                <a:spcPct val="112000"/>
+              </a:lnSpc>
+              <a:buNone/>
+            </a:pPr>
+            <a:r>
+              <a:rPr lang="zh-CN" altLang="en-US" sz="1050">
+                <a:solidFill>
+                  <a:srgbClr val="44546A"/>
+                </a:solidFill>
+                <a:latin typeface="微软雅黑"/>
+                <a:ea typeface="微软雅黑"/>
+                <a:cs typeface="微软雅黑"/>
+              </a:rPr>
+              <a:t>神经科学 × 脑类器官 × 产业转化</a:t>
+            </a:r>
+          </a:p>
+        </p:txBody>
+      </p:sp>
+      <p:sp>
+        <p:nvSpPr>
+          <p:cNvPr id="310" name="经历 2"/>
+          <p:cNvSpPr txBox="1"/>
+          <p:nvPr/>
+        </p:nvSpPr>
+        <p:spPr>
+          <a:xfrm>
+            <a:off x="3454146" y="3456432"/>
+            <a:ext cx="2484882" cy="2606040"/>
+          </a:xfrm>
+          <a:prstGeom prst="rect">
+            <a:avLst/>
+          </a:prstGeom>
+          <a:noFill/>
+        </p:spPr>
+        <p:txBody>
+          <a:bodyPr wrap="square" lIns="0" tIns="0" rIns="0" bIns="0" anchor="t">
+            <a:noAutofit/>
+          </a:bodyPr>
+          <a:lstStyle/>
+          <a:p>
+            <a:pPr algn="l" marL="190500" indent="-190500">
+              <a:lnSpc>
+                <a:spcPct val="110000"/>
+              </a:lnSpc>
+              <a:spcAft>
+                <a:spcPts val="450"/>
+              </a:spcAft>
+              <a:buClr>
+                <a:srgbClr val="08A6F6"/>
+              </a:buClr>
+              <a:buFont typeface="Arial"/>
+              <a:buChar char="•"/>
+            </a:pPr>
+            <a:r>
+              <a:rPr lang="zh-CN" altLang="en-US" sz="1150">
+                <a:solidFill>
+                  <a:srgbClr val="061F32"/>
+                </a:solidFill>
+                <a:latin typeface="微软雅黑"/>
+                <a:ea typeface="微软雅黑"/>
+                <a:cs typeface="微软雅黑"/>
+              </a:rPr>
+              <a:t>DKFZ / 海德堡大学与德国癌症研究中心联合研究中心博士后 / 资深科学家（神经科学）/ 慕尼黑大学博士</a:t>
+            </a:r>
+          </a:p>
+          <a:p>
+            <a:pPr algn="l" marL="190500" indent="-190500">
+              <a:lnSpc>
+                <a:spcPct val="110000"/>
+              </a:lnSpc>
+              <a:spcAft>
+                <a:spcPts val="450"/>
+              </a:spcAft>
+              <a:buClr>
+                <a:srgbClr val="08A6F6"/>
+              </a:buClr>
+              <a:buFont typeface="Arial"/>
+              <a:buChar char="•"/>
+            </a:pPr>
+            <a:r>
+              <a:rPr lang="zh-CN" altLang="en-US" sz="1150">
+                <a:solidFill>
+                  <a:srgbClr val="061F32"/>
+                </a:solidFill>
+                <a:latin typeface="微软雅黑"/>
+                <a:ea typeface="微软雅黑"/>
+                <a:cs typeface="微软雅黑"/>
+              </a:rPr>
+              <a:t>精通湿实验及各种小动物及类器官模型</a:t>
+            </a:r>
+          </a:p>
+          <a:p>
+            <a:pPr algn="l" marL="190500" indent="-190500">
+              <a:lnSpc>
+                <a:spcPct val="110000"/>
+              </a:lnSpc>
+              <a:spcAft>
+                <a:spcPts val="450"/>
+              </a:spcAft>
+              <a:buClr>
+                <a:srgbClr val="08A6F6"/>
+              </a:buClr>
+              <a:buFont typeface="Arial"/>
+              <a:buChar char="•"/>
+            </a:pPr>
+            <a:r>
+              <a:rPr lang="zh-CN" altLang="en-US" sz="1150">
+                <a:solidFill>
+                  <a:srgbClr val="061F32"/>
+                </a:solidFill>
+                <a:latin typeface="微软雅黑"/>
+                <a:ea typeface="微软雅黑"/>
+                <a:cs typeface="微软雅黑"/>
+              </a:rPr>
+              <a:t>主持欧中重大科研项目</a:t>
+            </a:r>
+          </a:p>
+          <a:p>
+            <a:pPr algn="l" marL="190500" indent="-190500">
+              <a:lnSpc>
+                <a:spcPct val="110000"/>
+              </a:lnSpc>
+              <a:spcAft>
+                <a:spcPts val="450"/>
+              </a:spcAft>
+              <a:buClr>
+                <a:srgbClr val="08A6F6"/>
+              </a:buClr>
+              <a:buFont typeface="Arial"/>
+              <a:buChar char="•"/>
+            </a:pPr>
+            <a:r>
+              <a:rPr lang="zh-CN" altLang="en-US" sz="1150">
+                <a:solidFill>
+                  <a:srgbClr val="061F32"/>
+                </a:solidFill>
+                <a:latin typeface="微软雅黑"/>
+                <a:ea typeface="微软雅黑"/>
+                <a:cs typeface="微软雅黑"/>
+              </a:rPr>
+              <a:t>深耕神经调控与脑类器官方向，长期研究胶质母细胞瘤复发与耐药</a:t>
+            </a:r>
+          </a:p>
+          <a:p>
+            <a:pPr algn="l" marL="190500" indent="-190500">
+              <a:lnSpc>
+                <a:spcPct val="110000"/>
+              </a:lnSpc>
+              <a:spcAft>
+                <a:spcPts val="450"/>
+              </a:spcAft>
+              <a:buClr>
+                <a:srgbClr val="08A6F6"/>
+              </a:buClr>
+              <a:buFont typeface="Arial"/>
+              <a:buChar char="•"/>
+            </a:pPr>
+            <a:r>
+              <a:rPr lang="zh-CN" altLang="en-US" sz="1150">
+                <a:solidFill>
+                  <a:srgbClr val="061F32"/>
+                </a:solidFill>
+                <a:latin typeface="微软雅黑"/>
+                <a:ea typeface="微软雅黑"/>
+                <a:cs typeface="微软雅黑"/>
+              </a:rPr>
+              <a:t>Cell Stem Cell 2025、npj Precision Oncology 2024 核心成员</a:t>
+            </a:r>
+          </a:p>
+        </p:txBody>
+      </p:sp>
+      <p:pic>
+        <p:nvPicPr>
+          <p:cNvPr id="311" name="照片 3"/>
+          <p:cNvPicPr>
+            <a:picLocks noChangeAspect="1"/>
+          </p:cNvPicPr>
+          <p:nvPr/>
+        </p:nvPicPr>
+        <p:blipFill>
+          <a:blip r:embed="rIdPh3"/>
+          <a:stretch>
+            <a:fillRect/>
+          </a:stretch>
+        </p:blipFill>
+        <p:spPr>
+          <a:xfrm>
+            <a:off x="6879717" y="1005840"/>
+            <a:ext cx="1280160" cy="1280160"/>
+          </a:xfrm>
+          <a:prstGeom prst="ellipse">
+            <a:avLst/>
+          </a:prstGeom>
+          <a:ln w="12700">
+            <a:solidFill>
+              <a:srgbClr val="99BDED"/>
+            </a:solidFill>
+          </a:ln>
+        </p:spPr>
+      </p:pic>
+      <p:sp>
+        <p:nvSpPr>
+          <p:cNvPr id="312" name="姓名 3"/>
+          <p:cNvSpPr txBox="1"/>
+          <p:nvPr/>
+        </p:nvSpPr>
+        <p:spPr>
+          <a:xfrm>
+            <a:off x="6231636" y="2404872"/>
+            <a:ext cx="2576322" cy="329184"/>
+          </a:xfrm>
+          <a:prstGeom prst="rect">
+            <a:avLst/>
+          </a:prstGeom>
+          <a:noFill/>
+        </p:spPr>
+        <p:txBody>
+          <a:bodyPr wrap="square" lIns="0" tIns="0" rIns="0" bIns="0" anchor="ctr">
+            <a:noAutofit/>
+          </a:bodyPr>
+          <a:lstStyle/>
+          <a:p>
+            <a:pPr algn="ctr">
+              <a:lnSpc>
+                <a:spcPct val="112000"/>
+              </a:lnSpc>
+              <a:buNone/>
+            </a:pPr>
+            <a:r>
+              <a:rPr lang="zh-CN" altLang="en-US" sz="1600" b="1">
+                <a:solidFill>
+                  <a:srgbClr val="061F32"/>
+                </a:solidFill>
+                <a:latin typeface="微软雅黑"/>
+                <a:ea typeface="微软雅黑"/>
+                <a:cs typeface="微软雅黑"/>
+              </a:rPr>
+              <a:t>王中杰 博士</a:t>
+            </a:r>
+          </a:p>
+        </p:txBody>
+      </p:sp>
+      <p:sp>
+        <p:nvSpPr>
+          <p:cNvPr id="313" name="职位 3"/>
+          <p:cNvSpPr txBox="1"/>
+          <p:nvPr/>
+        </p:nvSpPr>
+        <p:spPr>
+          <a:xfrm>
+            <a:off x="6231636" y="2724912"/>
+            <a:ext cx="2576322" cy="274320"/>
+          </a:xfrm>
+          <a:prstGeom prst="rect">
+            <a:avLst/>
+          </a:prstGeom>
+          <a:noFill/>
+        </p:spPr>
+        <p:txBody>
+          <a:bodyPr wrap="square" lIns="0" tIns="0" rIns="0" bIns="0" anchor="ctr">
+            <a:noAutofit/>
+          </a:bodyPr>
+          <a:lstStyle/>
+          <a:p>
+            <a:pPr algn="ctr">
+              <a:lnSpc>
+                <a:spcPct val="112000"/>
+              </a:lnSpc>
+              <a:buNone/>
+            </a:pPr>
+            <a:r>
+              <a:rPr lang="zh-CN" altLang="en-US" sz="1300" b="1">
+                <a:solidFill>
+                  <a:srgbClr val="08A6F6"/>
+                </a:solidFill>
+                <a:latin typeface="微软雅黑"/>
+                <a:ea typeface="微软雅黑"/>
+                <a:cs typeface="微软雅黑"/>
+              </a:rPr>
+              <a:t>CTO 首席技术官</a:t>
+            </a:r>
+          </a:p>
+        </p:txBody>
+      </p:sp>
+      <p:sp>
+        <p:nvSpPr>
+          <p:cNvPr id="314" name="亮点 3"/>
+          <p:cNvSpPr txBox="1"/>
+          <p:nvPr/>
+        </p:nvSpPr>
+        <p:spPr>
+          <a:xfrm>
+            <a:off x="6231636" y="3017520"/>
+            <a:ext cx="2576322" cy="256032"/>
+          </a:xfrm>
+          <a:prstGeom prst="rect">
+            <a:avLst/>
+          </a:prstGeom>
+          <a:noFill/>
+        </p:spPr>
+        <p:txBody>
+          <a:bodyPr wrap="square" lIns="0" tIns="0" rIns="0" bIns="0" anchor="ctr">
+            <a:noAutofit/>
+          </a:bodyPr>
+          <a:lstStyle/>
+          <a:p>
+            <a:pPr algn="ctr">
+              <a:lnSpc>
+                <a:spcPct val="112000"/>
+              </a:lnSpc>
+              <a:buNone/>
+            </a:pPr>
+            <a:r>
+              <a:rPr lang="zh-CN" altLang="en-US" sz="1050">
+                <a:solidFill>
+                  <a:srgbClr val="44546A"/>
+                </a:solidFill>
+                <a:latin typeface="微软雅黑"/>
+                <a:ea typeface="微软雅黑"/>
+                <a:cs typeface="微软雅黑"/>
+              </a:rPr>
+              <a:t>生物信息 × 机器学习预测建模</a:t>
+            </a:r>
+          </a:p>
+        </p:txBody>
+      </p:sp>
+      <p:sp>
+        <p:nvSpPr>
+          <p:cNvPr id="315" name="经历 3"/>
+          <p:cNvSpPr txBox="1"/>
+          <p:nvPr/>
+        </p:nvSpPr>
+        <p:spPr>
+          <a:xfrm>
+            <a:off x="6304788" y="3456432"/>
+            <a:ext cx="2484882" cy="2606040"/>
+          </a:xfrm>
+          <a:prstGeom prst="rect">
+            <a:avLst/>
+          </a:prstGeom>
+          <a:noFill/>
+        </p:spPr>
+        <p:txBody>
+          <a:bodyPr wrap="square" lIns="0" tIns="0" rIns="0" bIns="0" anchor="t">
+            <a:noAutofit/>
+          </a:bodyPr>
+          <a:lstStyle/>
+          <a:p>
+            <a:pPr algn="l" marL="190500" indent="-190500">
+              <a:lnSpc>
+                <a:spcPct val="110000"/>
+              </a:lnSpc>
+              <a:spcAft>
+                <a:spcPts val="450"/>
+              </a:spcAft>
+              <a:buClr>
+                <a:srgbClr val="08A6F6"/>
+              </a:buClr>
+              <a:buFont typeface="Arial"/>
+              <a:buChar char="•"/>
+            </a:pPr>
+            <a:r>
+              <a:rPr lang="zh-CN" altLang="en-US" sz="1150">
+                <a:solidFill>
+                  <a:srgbClr val="061F32"/>
+                </a:solidFill>
+                <a:latin typeface="微软雅黑"/>
+                <a:ea typeface="微软雅黑"/>
+                <a:cs typeface="微软雅黑"/>
+              </a:rPr>
+              <a:t>哈佛医学院，巴斯德研究所博士后研究员</a:t>
+            </a:r>
+          </a:p>
+          <a:p>
+            <a:pPr algn="l" marL="190500" indent="-190500">
+              <a:lnSpc>
+                <a:spcPct val="110000"/>
+              </a:lnSpc>
+              <a:spcAft>
+                <a:spcPts val="450"/>
+              </a:spcAft>
+              <a:buClr>
+                <a:srgbClr val="08A6F6"/>
+              </a:buClr>
+              <a:buFont typeface="Arial"/>
+              <a:buChar char="•"/>
+            </a:pPr>
+            <a:r>
+              <a:rPr lang="zh-CN" altLang="en-US" sz="1150">
+                <a:solidFill>
+                  <a:srgbClr val="061F32"/>
+                </a:solidFill>
+                <a:latin typeface="微软雅黑"/>
+                <a:ea typeface="微软雅黑"/>
+                <a:cs typeface="微软雅黑"/>
+              </a:rPr>
+              <a:t>慕尼黑工业大学 / 慕尼黑亥姆霍兹中心博士</a:t>
+            </a:r>
+          </a:p>
+          <a:p>
+            <a:pPr algn="l" marL="190500" indent="-190500">
+              <a:lnSpc>
+                <a:spcPct val="110000"/>
+              </a:lnSpc>
+              <a:spcAft>
+                <a:spcPts val="450"/>
+              </a:spcAft>
+              <a:buClr>
+                <a:srgbClr val="08A6F6"/>
+              </a:buClr>
+              <a:buFont typeface="Arial"/>
+              <a:buChar char="•"/>
+            </a:pPr>
+            <a:r>
+              <a:rPr lang="zh-CN" altLang="en-US" sz="1150">
+                <a:solidFill>
+                  <a:srgbClr val="061F32"/>
+                </a:solidFill>
+                <a:latin typeface="微软雅黑"/>
+                <a:ea typeface="微软雅黑"/>
+                <a:cs typeface="微软雅黑"/>
+              </a:rPr>
+              <a:t>近 10 年生物信息与多组学数据分析经验</a:t>
+            </a:r>
+          </a:p>
+          <a:p>
+            <a:pPr algn="l" marL="190500" indent="-190500">
+              <a:lnSpc>
+                <a:spcPct val="110000"/>
+              </a:lnSpc>
+              <a:spcAft>
+                <a:spcPts val="450"/>
+              </a:spcAft>
+              <a:buClr>
+                <a:srgbClr val="08A6F6"/>
+              </a:buClr>
+              <a:buFont typeface="Arial"/>
+              <a:buChar char="•"/>
+            </a:pPr>
+            <a:r>
+              <a:rPr lang="zh-CN" altLang="en-US" sz="1150">
+                <a:solidFill>
+                  <a:srgbClr val="061F32"/>
+                </a:solidFill>
+                <a:latin typeface="微软雅黑"/>
+                <a:ea typeface="微软雅黑"/>
+                <a:cs typeface="微软雅黑"/>
+              </a:rPr>
+              <a:t>精通大规模计算与机器学习预测建模</a:t>
+            </a:r>
+          </a:p>
+          <a:p>
+            <a:pPr algn="l" marL="190500" indent="-190500">
+              <a:lnSpc>
+                <a:spcPct val="110000"/>
+              </a:lnSpc>
+              <a:spcAft>
+                <a:spcPts val="450"/>
+              </a:spcAft>
+              <a:buClr>
+                <a:srgbClr val="08A6F6"/>
+              </a:buClr>
+              <a:buFont typeface="Arial"/>
+              <a:buChar char="•"/>
+            </a:pPr>
+            <a:r>
+              <a:rPr lang="zh-CN" altLang="en-US" sz="1150">
+                <a:solidFill>
+                  <a:srgbClr val="061F32"/>
+                </a:solidFill>
+                <a:latin typeface="微软雅黑"/>
+                <a:ea typeface="微软雅黑"/>
+                <a:cs typeface="微软雅黑"/>
+              </a:rPr>
+              <a:t>擅长搭建端到端可复用分析流程，支撑临床与生物医药项目的数据挖掘与决策输出</a:t>
+            </a:r>
+          </a:p>
+        </p:txBody>
+      </p:sp>
+      <p:pic>
+        <p:nvPicPr>
+          <p:cNvPr id="316" name="照片 4"/>
+          <p:cNvPicPr>
+            <a:picLocks noChangeAspect="1"/>
+          </p:cNvPicPr>
+          <p:nvPr/>
+        </p:nvPicPr>
+        <p:blipFill>
+          <a:blip r:embed="rIdPh4"/>
+          <a:stretch>
+            <a:fillRect/>
+          </a:stretch>
+        </p:blipFill>
+        <p:spPr>
+          <a:xfrm>
+            <a:off x="9730359" y="1005840"/>
+            <a:ext cx="1280160" cy="1280160"/>
+          </a:xfrm>
+          <a:prstGeom prst="ellipse">
+            <a:avLst/>
+          </a:prstGeom>
+          <a:ln w="12700">
+            <a:solidFill>
+              <a:srgbClr val="99BDED"/>
+            </a:solidFill>
+          </a:ln>
+        </p:spPr>
+      </p:pic>
+      <p:sp>
+        <p:nvSpPr>
+          <p:cNvPr id="317" name="姓名 4"/>
+          <p:cNvSpPr txBox="1"/>
+          <p:nvPr/>
+        </p:nvSpPr>
+        <p:spPr>
+          <a:xfrm>
+            <a:off x="9082278" y="2404872"/>
+            <a:ext cx="2576322" cy="329184"/>
+          </a:xfrm>
+          <a:prstGeom prst="rect">
+            <a:avLst/>
+          </a:prstGeom>
+          <a:noFill/>
+        </p:spPr>
+        <p:txBody>
+          <a:bodyPr wrap="square" lIns="0" tIns="0" rIns="0" bIns="0" anchor="ctr">
+            <a:noAutofit/>
+          </a:bodyPr>
+          <a:lstStyle/>
+          <a:p>
+            <a:pPr algn="ctr">
+              <a:lnSpc>
+                <a:spcPct val="112000"/>
+              </a:lnSpc>
+              <a:buNone/>
+            </a:pPr>
+            <a:r>
+              <a:rPr lang="zh-CN" altLang="en-US" sz="1600" b="1">
+                <a:solidFill>
+                  <a:srgbClr val="061F32"/>
+                </a:solidFill>
+                <a:latin typeface="微软雅黑"/>
+                <a:ea typeface="微软雅黑"/>
+                <a:cs typeface="微软雅黑"/>
+              </a:rPr>
+              <a:t>兰晓静</a:t>
+            </a:r>
+          </a:p>
+        </p:txBody>
+      </p:sp>
+      <p:sp>
+        <p:nvSpPr>
+          <p:cNvPr id="318" name="职位 4"/>
+          <p:cNvSpPr txBox="1"/>
+          <p:nvPr/>
+        </p:nvSpPr>
+        <p:spPr>
+          <a:xfrm>
+            <a:off x="9082278" y="2724912"/>
+            <a:ext cx="2576322" cy="274320"/>
+          </a:xfrm>
+          <a:prstGeom prst="rect">
+            <a:avLst/>
+          </a:prstGeom>
+          <a:noFill/>
+        </p:spPr>
+        <p:txBody>
+          <a:bodyPr wrap="square" lIns="0" tIns="0" rIns="0" bIns="0" anchor="ctr">
+            <a:noAutofit/>
+          </a:bodyPr>
+          <a:lstStyle/>
+          <a:p>
+            <a:pPr algn="ctr">
+              <a:lnSpc>
+                <a:spcPct val="112000"/>
+              </a:lnSpc>
+              <a:buNone/>
+            </a:pPr>
+            <a:r>
+              <a:rPr lang="zh-CN" altLang="en-US" sz="1300" b="1">
+                <a:solidFill>
+                  <a:srgbClr val="08A6F6"/>
+                </a:solidFill>
+                <a:latin typeface="微软雅黑"/>
+                <a:ea typeface="微软雅黑"/>
+                <a:cs typeface="微软雅黑"/>
+              </a:rPr>
+              <a:t>COO 首席运营官</a:t>
+            </a:r>
+          </a:p>
+        </p:txBody>
+      </p:sp>
+      <p:sp>
+        <p:nvSpPr>
+          <p:cNvPr id="319" name="亮点 4"/>
+          <p:cNvSpPr txBox="1"/>
+          <p:nvPr/>
+        </p:nvSpPr>
+        <p:spPr>
+          <a:xfrm>
+            <a:off x="9082278" y="3017520"/>
+            <a:ext cx="2576322" cy="256032"/>
+          </a:xfrm>
+          <a:prstGeom prst="rect">
+            <a:avLst/>
+          </a:prstGeom>
+          <a:noFill/>
+        </p:spPr>
+        <p:txBody>
+          <a:bodyPr wrap="square" lIns="0" tIns="0" rIns="0" bIns="0" anchor="ctr">
+            <a:noAutofit/>
+          </a:bodyPr>
+          <a:lstStyle/>
+          <a:p>
+            <a:pPr algn="ctr">
+              <a:lnSpc>
+                <a:spcPct val="112000"/>
+              </a:lnSpc>
+              <a:buNone/>
+            </a:pPr>
+            <a:r>
+              <a:rPr lang="zh-CN" altLang="en-US" sz="1050">
+                <a:solidFill>
+                  <a:srgbClr val="44546A"/>
+                </a:solidFill>
+                <a:latin typeface="微软雅黑"/>
+                <a:ea typeface="微软雅黑"/>
+                <a:cs typeface="微软雅黑"/>
+              </a:rPr>
+              <a:t>跨境金融风控 × 科创运营</a:t>
+            </a:r>
+          </a:p>
+        </p:txBody>
+      </p:sp>
+      <p:sp>
+        <p:nvSpPr>
+          <p:cNvPr id="320" name="经历 4"/>
+          <p:cNvSpPr txBox="1"/>
+          <p:nvPr/>
+        </p:nvSpPr>
+        <p:spPr>
+          <a:xfrm>
+            <a:off x="9155430" y="3456432"/>
+            <a:ext cx="2484882" cy="2606040"/>
+          </a:xfrm>
+          <a:prstGeom prst="rect">
+            <a:avLst/>
+          </a:prstGeom>
+          <a:noFill/>
+        </p:spPr>
+        <p:txBody>
+          <a:bodyPr wrap="square" lIns="0" tIns="0" rIns="0" bIns="0" anchor="t">
+            <a:noAutofit/>
+          </a:bodyPr>
+          <a:lstStyle/>
+          <a:p>
+            <a:pPr algn="l" marL="190500" indent="-190500">
+              <a:lnSpc>
+                <a:spcPct val="110000"/>
+              </a:lnSpc>
+              <a:spcAft>
+                <a:spcPts val="450"/>
+              </a:spcAft>
+              <a:buClr>
+                <a:srgbClr val="08A6F6"/>
+              </a:buClr>
+              <a:buFont typeface="Arial"/>
+              <a:buChar char="•"/>
+            </a:pPr>
+            <a:r>
+              <a:rPr lang="zh-CN" altLang="en-US" sz="1150">
+                <a:solidFill>
+                  <a:srgbClr val="061F32"/>
+                </a:solidFill>
+                <a:latin typeface="微软雅黑"/>
+                <a:ea typeface="微软雅黑"/>
+                <a:cs typeface="微软雅黑"/>
+              </a:rPr>
+              <a:t>海德堡大学经济学硕士</a:t>
+            </a:r>
+          </a:p>
+          <a:p>
+            <a:pPr algn="l" marL="190500" indent="-190500">
+              <a:lnSpc>
+                <a:spcPct val="110000"/>
+              </a:lnSpc>
+              <a:spcAft>
+                <a:spcPts val="450"/>
+              </a:spcAft>
+              <a:buClr>
+                <a:srgbClr val="08A6F6"/>
+              </a:buClr>
+              <a:buFont typeface="Arial"/>
+              <a:buChar char="•"/>
+            </a:pPr>
+            <a:r>
+              <a:rPr lang="zh-CN" altLang="en-US" sz="1150">
+                <a:solidFill>
+                  <a:srgbClr val="061F32"/>
+                </a:solidFill>
+                <a:latin typeface="微软雅黑"/>
+                <a:ea typeface="微软雅黑"/>
+                <a:cs typeface="微软雅黑"/>
+              </a:rPr>
+              <a:t>浙江大学管理学学士；竺可桢学院创业与创新管理强化班</a:t>
+            </a:r>
+          </a:p>
+          <a:p>
+            <a:pPr algn="l" marL="190500" indent="-190500">
+              <a:lnSpc>
+                <a:spcPct val="110000"/>
+              </a:lnSpc>
+              <a:spcAft>
+                <a:spcPts val="450"/>
+              </a:spcAft>
+              <a:buClr>
+                <a:srgbClr val="08A6F6"/>
+              </a:buClr>
+              <a:buFont typeface="Arial"/>
+              <a:buChar char="•"/>
+            </a:pPr>
+            <a:r>
+              <a:rPr lang="zh-CN" altLang="en-US" sz="1150">
+                <a:solidFill>
+                  <a:srgbClr val="061F32"/>
+                </a:solidFill>
+                <a:latin typeface="微软雅黑"/>
+                <a:ea typeface="微软雅黑"/>
+                <a:cs typeface="微软雅黑"/>
+              </a:rPr>
+              <a:t>FRM 持证人</a:t>
+            </a:r>
+          </a:p>
+          <a:p>
+            <a:pPr algn="l" marL="190500" indent="-190500">
+              <a:lnSpc>
+                <a:spcPct val="110000"/>
+              </a:lnSpc>
+              <a:spcAft>
+                <a:spcPts val="450"/>
+              </a:spcAft>
+              <a:buClr>
+                <a:srgbClr val="08A6F6"/>
+              </a:buClr>
+              <a:buFont typeface="Arial"/>
+              <a:buChar char="•"/>
+            </a:pPr>
+            <a:r>
+              <a:rPr lang="zh-CN" altLang="en-US" sz="1150">
+                <a:solidFill>
+                  <a:srgbClr val="061F32"/>
+                </a:solidFill>
+                <a:latin typeface="微软雅黑"/>
+                <a:ea typeface="微软雅黑"/>
+                <a:cs typeface="微软雅黑"/>
+              </a:rPr>
+              <a:t>多年国际金融机构风控合规与跨境尽调经验</a:t>
+            </a:r>
+          </a:p>
+          <a:p>
+            <a:pPr algn="l" marL="190500" indent="-190500">
+              <a:lnSpc>
+                <a:spcPct val="110000"/>
+              </a:lnSpc>
+              <a:spcAft>
+                <a:spcPts val="450"/>
+              </a:spcAft>
+              <a:buClr>
+                <a:srgbClr val="08A6F6"/>
+              </a:buClr>
+              <a:buFont typeface="Arial"/>
+              <a:buChar char="•"/>
+            </a:pPr>
+            <a:r>
+              <a:rPr lang="zh-CN" altLang="en-US" sz="1150">
+                <a:solidFill>
+                  <a:srgbClr val="061F32"/>
+                </a:solidFill>
+                <a:latin typeface="微软雅黑"/>
+                <a:ea typeface="微软雅黑"/>
+                <a:cs typeface="微软雅黑"/>
+              </a:rPr>
+              <a:t>精通跨境财务统筹、合规体系搭建与硬科技项目运营</a:t>
+            </a:r>
+          </a:p>
+        </p:txBody>
+      </p:sp>
+      <p:sp>
+        <p:nvSpPr>
+          <p:cNvPr id="101" name="文本框 77"/>
+          <p:cNvSpPr>
+            <a:spLocks noGrp="1"/>
+          </p:cNvSpPr>
+          <p:nvPr/>
+        </p:nvSpPr>
+        <p:spPr>
+          <a:xfrm>
+            <a:off x="530352" y="6163056"/>
+            <a:ext cx="10515600" cy="164592"/>
+          </a:xfrm>
+          <a:prstGeom prst="rect">
+            <a:avLst/>
+          </a:prstGeom>
+        </p:spPr>
+        <p:txBody>
+          <a:bodyPr wrap="none" lIns="0" tIns="0" rIns="0" bIns="0"/>
+          <a:lstStyle/>
+          <a:p>
+            <a:pPr>
+              <a:lnSpc>
+                <a:spcPct val="100000"/>
+              </a:lnSpc>
+              <a:buNone/>
+            </a:pPr>
+            <a:r>
+              <a:rPr sz="1050">
+                <a:solidFill>
+                  <a:srgbClr val="808080"/>
+                </a:solidFill>
+                <a:latin typeface="微软雅黑"/>
+                <a:ea typeface="微软雅黑"/>
+                <a:cs typeface="微软雅黑"/>
+              </a:rPr>
+              <a:t>Source: 团队成员简历</a:t>
+            </a:r>
+            <a:endParaRPr sz="1050">
+              <a:solidFill>
+                <a:srgbClr val="808080"/>
+              </a:solidFill>
+              <a:latin typeface="微软雅黑"/>
+              <a:ea typeface="微软雅黑"/>
+              <a:cs typeface="微软雅黑"/>
+            </a:endParaRPr>
+          </a:p>
+        </p:txBody>
+      </p:sp>
+      <p:sp>
+        <p:nvSpPr>
+          <p:cNvPr id="102" name="文本框 78"/>
+          <p:cNvSpPr>
+            <a:spLocks noGrp="1"/>
+          </p:cNvSpPr>
+          <p:nvPr/>
+        </p:nvSpPr>
+        <p:spPr>
+          <a:xfrm>
+            <a:off x="11201400" y="6381750"/>
+            <a:ext cx="457200" cy="161925"/>
+          </a:xfrm>
+          <a:prstGeom prst="rect">
+            <a:avLst/>
+          </a:prstGeom>
+        </p:spPr>
+        <p:txBody>
+          <a:bodyPr wrap="none" lIns="0" tIns="0" rIns="0" bIns="0"/>
+          <a:lstStyle/>
+          <a:p>
+            <a:pPr>
+              <a:lnSpc>
+                <a:spcPct val="100000"/>
+              </a:lnSpc>
+              <a:buNone/>
+            </a:pPr>
+            <a:r>
+              <a:rPr sz="1050">
+                <a:solidFill>
+                  <a:srgbClr val="808080"/>
+                </a:solidFill>
+                <a:latin typeface="微软雅黑"/>
+                <a:ea typeface="微软雅黑"/>
+                <a:cs typeface="微软雅黑"/>
+              </a:rPr>
+              <a:t>10 / 10</a:t>
+            </a:r>
+            <a:endParaRPr sz="1050">
+              <a:solidFill>
+                <a:srgbClr val="808080"/>
+              </a:solidFill>
+              <a:latin typeface="微软雅黑"/>
+              <a:ea typeface="微软雅黑"/>
+              <a:cs typeface="微软雅黑"/>
+            </a:endParaRPr>
+          </a:p>
+        </p:txBody>
+      </p:sp>
+      <p:sp>
+        <p:nvSpPr>
+          <p:cNvPr id="916" name="品牌页脚"/>
           <p:cNvSpPr txBox="1"/>
           <p:nvPr/>
         </p:nvSpPr>
@@ -7017,7 +8568,7 @@
                 <a:ea typeface="微软雅黑"/>
                 <a:cs typeface="微软雅黑"/>
               </a:rPr>
-              <a:t>04 / 09</a:t>
+              <a:t>04 / 10</a:t>
             </a:r>
             <a:endParaRPr sz="1050">
               <a:solidFill>
@@ -7590,7 +9141,7 @@
                 <a:ea typeface="微软雅黑"/>
                 <a:cs typeface="微软雅黑"/>
               </a:rPr>
-              <a:t>06 / 09</a:t>
+              <a:t>06 / 10</a:t>
             </a:r>
             <a:endParaRPr sz="1050">
               <a:solidFill>

</xml_diff>